<commit_message>
chore: finalize IndiaRuns submission
</commit_message>
<xml_diff>
--- a/outputs/redrob_ai_ranker_submission_deck.pptx
+++ b/outputs/redrob_ai_ranker_submission_deck.pptx
@@ -2,20 +2,20 @@
 <file path=ppt/presentation.xml><?xml version="1.0" encoding="utf-8"?>
 <p:presentation xmlns:p="http://schemas.openxmlformats.org/presentationml/2006/main">
   <p:sldMasterIdLst>
-    <p:sldMasterId xmlns:r="http://schemas.openxmlformats.org/officeDocument/2006/relationships" id="2147483648" r:id="R02733b516daa4e7a"/>
+    <p:sldMasterId xmlns:r="http://schemas.openxmlformats.org/officeDocument/2006/relationships" id="2147483648" r:id="Re2dc5e182a4b4722"/>
   </p:sldMasterIdLst>
   <p:notesMasterIdLst>
-    <p:notesMasterId xmlns:r="http://schemas.openxmlformats.org/officeDocument/2006/relationships" r:id="R94ff367a08a6445d"/>
+    <p:notesMasterId xmlns:r="http://schemas.openxmlformats.org/officeDocument/2006/relationships" r:id="Re83ebf239ac74201"/>
   </p:notesMasterIdLst>
   <p:sldIdLst>
-    <p:sldId xmlns:r="http://schemas.openxmlformats.org/officeDocument/2006/relationships" id="256" r:id="R3251f56d659a4ea0"/>
-    <p:sldId xmlns:r="http://schemas.openxmlformats.org/officeDocument/2006/relationships" id="257" r:id="R89895c24c40e49a6"/>
-    <p:sldId xmlns:r="http://schemas.openxmlformats.org/officeDocument/2006/relationships" id="258" r:id="Re4bea2ce8f9545c4"/>
-    <p:sldId xmlns:r="http://schemas.openxmlformats.org/officeDocument/2006/relationships" id="259" r:id="R1b5dfc98a8c84c11"/>
-    <p:sldId xmlns:r="http://schemas.openxmlformats.org/officeDocument/2006/relationships" id="260" r:id="R463c22b404df4667"/>
-    <p:sldId xmlns:r="http://schemas.openxmlformats.org/officeDocument/2006/relationships" id="261" r:id="R43ac35b31c534ba7"/>
-    <p:sldId xmlns:r="http://schemas.openxmlformats.org/officeDocument/2006/relationships" id="262" r:id="Ra60c77647ead48cf"/>
-    <p:sldId xmlns:r="http://schemas.openxmlformats.org/officeDocument/2006/relationships" id="263" r:id="R1aa967afa4c54fbe"/>
+    <p:sldId xmlns:r="http://schemas.openxmlformats.org/officeDocument/2006/relationships" id="256" r:id="R3232038feb974777"/>
+    <p:sldId xmlns:r="http://schemas.openxmlformats.org/officeDocument/2006/relationships" id="257" r:id="R79edf7c962c748f4"/>
+    <p:sldId xmlns:r="http://schemas.openxmlformats.org/officeDocument/2006/relationships" id="258" r:id="Rbb3a27d52fea4c08"/>
+    <p:sldId xmlns:r="http://schemas.openxmlformats.org/officeDocument/2006/relationships" id="259" r:id="R4874f2233ccd407f"/>
+    <p:sldId xmlns:r="http://schemas.openxmlformats.org/officeDocument/2006/relationships" id="260" r:id="R137ce91423aa4c24"/>
+    <p:sldId xmlns:r="http://schemas.openxmlformats.org/officeDocument/2006/relationships" id="261" r:id="Recc6f13ee3814ee8"/>
+    <p:sldId xmlns:r="http://schemas.openxmlformats.org/officeDocument/2006/relationships" id="262" r:id="R45c1cec099b24f0a"/>
+    <p:sldId xmlns:r="http://schemas.openxmlformats.org/officeDocument/2006/relationships" id="263" r:id="Rf6b882554e9c43b1"/>
   </p:sldIdLst>
   <p:sldSz cx="12192000" cy="6858000"/>
   <p:notesSz cx="6858000" cy="9144000"/>
@@ -1070,7 +1070,7 @@
   </p:cSld>
   <p:clrMap bg1="lt1" tx1="dk1" bg2="lt2" tx2="dk2" accent1="accent1" accent2="accent2" accent3="accent3" accent4="accent4" accent5="accent5" accent6="accent6" hlink="hlink" folHlink="folHlink"/>
   <p:sldLayoutIdLst>
-    <p:sldLayoutId xmlns:r="http://schemas.openxmlformats.org/officeDocument/2006/relationships" id="2147483649" r:id="R217cf827fa744dcb"/>
+    <p:sldLayoutId xmlns:r="http://schemas.openxmlformats.org/officeDocument/2006/relationships" id="2147483649" r:id="Ra0607e75e50343d4"/>
   </p:sldLayoutIdLst>
   <p:txStyles>
     <p:titleStyle>
@@ -3043,6 +3043,62 @@
           </a:p>
         </p:txBody>
       </p:sp>
+      <p:sp>
+        <p:nvSpPr>
+          <p:cNvPr id="28" name="">
+            <a:extLst xmlns:a="http://schemas.openxmlformats.org/drawingml/2006/main">
+              <a:ext uri="{FF2B5EF4-FFF2-40B4-BE49-F238E27FC236}">
+                <a16:creationId xmlns:a16="http://schemas.microsoft.com/office/drawing/2014/main" id="{AC59F148-6F81-41A2-BB5A-EDC2B32313DF}"/>
+              </a:ext>
+            </a:extLst>
+          </p:cNvPr>
+          <p:cNvSpPr>
+            <a:spLocks xmlns:a="http://schemas.openxmlformats.org/drawingml/2006/main" noGrp="1"/>
+          </p:cNvSpPr>
+          <p:nvPr/>
+        </p:nvSpPr>
+        <p:spPr>
+          <a:xfrm xmlns:a="http://schemas.openxmlformats.org/drawingml/2006/main">
+            <a:off x="6191250" y="495300"/>
+            <a:ext cx="5429250" cy="247650"/>
+          </a:xfrm>
+          <a:prstGeom xmlns:a="http://schemas.openxmlformats.org/drawingml/2006/main" prst="rect">
+            <a:avLst/>
+          </a:prstGeom>
+          <a:noFill xmlns:a="http://schemas.openxmlformats.org/drawingml/2006/main"/>
+          <a:ln xmlns:a="http://schemas.openxmlformats.org/drawingml/2006/main" w="0">
+            <a:noFill/>
+            <a:prstDash val="solid"/>
+          </a:ln>
+        </p:spPr>
+        <p:txBody>
+          <a:bodyPr xmlns:a="http://schemas.openxmlformats.org/drawingml/2006/main" anchor="ctr"/>
+          <a:lstStyle xmlns:a="http://schemas.openxmlformats.org/drawingml/2006/main"/>
+          <a:p xmlns:a="http://schemas.openxmlformats.org/drawingml/2006/main">
+            <a:pPr algn="r">
+              <a:defRPr sz="750" b="1">
+                <a:solidFill>
+                  <a:srgbClr val="9FB0C5"/>
+                </a:solidFill>
+                <a:latin typeface="Aptos"/>
+                <a:ea typeface="Aptos"/>
+                <a:cs typeface="Aptos"/>
+              </a:defRPr>
+            </a:pPr>
+            <a:r>
+              <a:rPr sz="750" b="1">
+                <a:solidFill>
+                  <a:srgbClr val="9FB0C5"/>
+                </a:solidFill>
+                <a:latin typeface="Aptos"/>
+                <a:ea typeface="Aptos"/>
+                <a:cs typeface="Aptos"/>
+              </a:rPr>
+              <a:t>THE INDIC PROTOCOL  ·  PARTICIPANT 686b95d376ce14837de12b88</a:t>
+            </a:r>
+          </a:p>
+        </p:txBody>
+      </p:sp>
     </p:spTree>
     <p:extLst>
       <p:ext uri="{BB962C8B-B14F-4D97-AF65-F5344CB8AC3E}">

</xml_diff>

<commit_message>
docs: clarify native and Docker runtimes
</commit_message>
<xml_diff>
--- a/outputs/redrob_ai_ranker_submission_deck.pptx
+++ b/outputs/redrob_ai_ranker_submission_deck.pptx
@@ -2,20 +2,20 @@
 <file path=ppt/presentation.xml><?xml version="1.0" encoding="utf-8"?>
 <p:presentation xmlns:p="http://schemas.openxmlformats.org/presentationml/2006/main">
   <p:sldMasterIdLst>
-    <p:sldMasterId xmlns:r="http://schemas.openxmlformats.org/officeDocument/2006/relationships" id="2147483648" r:id="Re2dc5e182a4b4722"/>
+    <p:sldMasterId xmlns:r="http://schemas.openxmlformats.org/officeDocument/2006/relationships" id="2147483648" r:id="Re4b55dc166e84f15"/>
   </p:sldMasterIdLst>
   <p:notesMasterIdLst>
-    <p:notesMasterId xmlns:r="http://schemas.openxmlformats.org/officeDocument/2006/relationships" r:id="Re83ebf239ac74201"/>
+    <p:notesMasterId xmlns:r="http://schemas.openxmlformats.org/officeDocument/2006/relationships" r:id="R79a2274e33764882"/>
   </p:notesMasterIdLst>
   <p:sldIdLst>
-    <p:sldId xmlns:r="http://schemas.openxmlformats.org/officeDocument/2006/relationships" id="256" r:id="R3232038feb974777"/>
-    <p:sldId xmlns:r="http://schemas.openxmlformats.org/officeDocument/2006/relationships" id="257" r:id="R79edf7c962c748f4"/>
-    <p:sldId xmlns:r="http://schemas.openxmlformats.org/officeDocument/2006/relationships" id="258" r:id="Rbb3a27d52fea4c08"/>
-    <p:sldId xmlns:r="http://schemas.openxmlformats.org/officeDocument/2006/relationships" id="259" r:id="R4874f2233ccd407f"/>
-    <p:sldId xmlns:r="http://schemas.openxmlformats.org/officeDocument/2006/relationships" id="260" r:id="R137ce91423aa4c24"/>
-    <p:sldId xmlns:r="http://schemas.openxmlformats.org/officeDocument/2006/relationships" id="261" r:id="Recc6f13ee3814ee8"/>
-    <p:sldId xmlns:r="http://schemas.openxmlformats.org/officeDocument/2006/relationships" id="262" r:id="R45c1cec099b24f0a"/>
-    <p:sldId xmlns:r="http://schemas.openxmlformats.org/officeDocument/2006/relationships" id="263" r:id="Rf6b882554e9c43b1"/>
+    <p:sldId xmlns:r="http://schemas.openxmlformats.org/officeDocument/2006/relationships" id="256" r:id="Ra51c653029d848bc"/>
+    <p:sldId xmlns:r="http://schemas.openxmlformats.org/officeDocument/2006/relationships" id="257" r:id="R4f69eae7d01a4101"/>
+    <p:sldId xmlns:r="http://schemas.openxmlformats.org/officeDocument/2006/relationships" id="258" r:id="Rbe38d9d76ad34281"/>
+    <p:sldId xmlns:r="http://schemas.openxmlformats.org/officeDocument/2006/relationships" id="259" r:id="R5cf0abe0d55a45bb"/>
+    <p:sldId xmlns:r="http://schemas.openxmlformats.org/officeDocument/2006/relationships" id="260" r:id="Ref596cfcab4b447a"/>
+    <p:sldId xmlns:r="http://schemas.openxmlformats.org/officeDocument/2006/relationships" id="261" r:id="R5009bde4797149ca"/>
+    <p:sldId xmlns:r="http://schemas.openxmlformats.org/officeDocument/2006/relationships" id="262" r:id="R7914cd640acb43f4"/>
+    <p:sldId xmlns:r="http://schemas.openxmlformats.org/officeDocument/2006/relationships" id="263" r:id="Rf7fc062af2d949d0"/>
   </p:sldIdLst>
   <p:sldSz cx="12192000" cy="6858000"/>
   <p:notesSz cx="6858000" cy="9144000"/>
@@ -1070,7 +1070,7 @@
   </p:cSld>
   <p:clrMap bg1="lt1" tx1="dk1" bg2="lt2" tx2="dk2" accent1="accent1" accent2="accent2" accent3="accent3" accent4="accent4" accent5="accent5" accent6="accent6" hlink="hlink" folHlink="folHlink"/>
   <p:sldLayoutIdLst>
-    <p:sldLayoutId xmlns:r="http://schemas.openxmlformats.org/officeDocument/2006/relationships" id="2147483649" r:id="Ra0607e75e50343d4"/>
+    <p:sldLayoutId xmlns:r="http://schemas.openxmlformats.org/officeDocument/2006/relationships" id="2147483649" r:id="R0e1967d474b14da6"/>
   </p:sldLayoutIdLst>
   <p:txStyles>
     <p:titleStyle>
@@ -2262,7 +2262,7 @@
                 <a:ea typeface="Aptos"/>
                 <a:cs typeface="Aptos"/>
               </a:rPr>
-              <a:t>full-pool runtime</a:t>
+              <a:t>native CPU runtime</a:t>
             </a:r>
           </a:p>
         </p:txBody>
@@ -2981,7 +2981,7 @@
                 <a:ea typeface="Aptos"/>
                 <a:cs typeface="Aptos"/>
               </a:rPr>
-              <a:t>Measured locally on the released 100,000-candidate pool</a:t>
+              <a:t>Native Windows CPU: 84.6s  |  Docker reproduction: 162.8s</a:t>
             </a:r>
           </a:p>
         </p:txBody>
@@ -3076,6 +3076,7 @@
           <a:lstStyle xmlns:a="http://schemas.openxmlformats.org/drawingml/2006/main"/>
           <a:p xmlns:a="http://schemas.openxmlformats.org/drawingml/2006/main">
             <a:pPr algn="r">
+              <a:buNone/>
               <a:defRPr sz="750" b="1">
                 <a:solidFill>
                   <a:srgbClr val="9FB0C5"/>
@@ -12737,7 +12738,7 @@
                 <a:ea typeface="Aptos"/>
                 <a:cs typeface="Aptos"/>
               </a:rPr>
-              <a:t>end-to-end CPU time</a:t>
+              <a:t>native CPU time</a:t>
             </a:r>
           </a:p>
         </p:txBody>
@@ -13127,7 +13128,7 @@
                 <a:ea typeface="Aptos"/>
                 <a:cs typeface="Aptos"/>
               </a:rPr>
-              <a:t>RUNTIME BREAKDOWN</a:t>
+              <a:t>NATIVE RUNTIME BREAKDOWN</a:t>
             </a:r>
           </a:p>
         </p:txBody>
@@ -14559,6 +14560,62 @@
                 <a:cs typeface="Aptos"/>
               </a:rPr>
               <a:t>74.7s</a:t>
+            </a:r>
+          </a:p>
+        </p:txBody>
+      </p:sp>
+      <p:sp>
+        <p:nvSpPr>
+          <p:cNvPr id="50" name="">
+            <a:extLst xmlns:a="http://schemas.openxmlformats.org/drawingml/2006/main">
+              <a:ext uri="{FF2B5EF4-FFF2-40B4-BE49-F238E27FC236}">
+                <a16:creationId xmlns:a16="http://schemas.microsoft.com/office/drawing/2014/main" id="{CE936396-9124-44D1-9B54-556240DDB099}"/>
+              </a:ext>
+            </a:extLst>
+          </p:cNvPr>
+          <p:cNvSpPr>
+            <a:spLocks xmlns:a="http://schemas.openxmlformats.org/drawingml/2006/main" noGrp="1"/>
+          </p:cNvSpPr>
+          <p:nvPr/>
+        </p:nvSpPr>
+        <p:spPr>
+          <a:xfrm xmlns:a="http://schemas.openxmlformats.org/drawingml/2006/main">
+            <a:off x="762000" y="5372100"/>
+            <a:ext cx="4619625" cy="228600"/>
+          </a:xfrm>
+          <a:prstGeom xmlns:a="http://schemas.openxmlformats.org/drawingml/2006/main" prst="rect">
+            <a:avLst/>
+          </a:prstGeom>
+          <a:noFill xmlns:a="http://schemas.openxmlformats.org/drawingml/2006/main"/>
+          <a:ln xmlns:a="http://schemas.openxmlformats.org/drawingml/2006/main" w="0">
+            <a:noFill/>
+            <a:prstDash val="solid"/>
+          </a:ln>
+        </p:spPr>
+        <p:txBody>
+          <a:bodyPr xmlns:a="http://schemas.openxmlformats.org/drawingml/2006/main" anchor="ctr"/>
+          <a:lstStyle xmlns:a="http://schemas.openxmlformats.org/drawingml/2006/main"/>
+          <a:p xmlns:a="http://schemas.openxmlformats.org/drawingml/2006/main">
+            <a:pPr algn="l">
+              <a:defRPr sz="750" b="1">
+                <a:solidFill>
+                  <a:srgbClr val="3CCBBF"/>
+                </a:solidFill>
+                <a:latin typeface="Aptos"/>
+                <a:ea typeface="Aptos"/>
+                <a:cs typeface="Aptos"/>
+              </a:defRPr>
+            </a:pPr>
+            <a:r>
+              <a:rPr sz="750" b="1">
+                <a:solidFill>
+                  <a:srgbClr val="3CCBBF"/>
+                </a:solidFill>
+                <a:latin typeface="Aptos"/>
+                <a:ea typeface="Aptos"/>
+                <a:cs typeface="Aptos"/>
+              </a:rPr>
+              <a:t>Docker reproduction: 162.8s  ·  identical output SHA-256</a:t>
             </a:r>
           </a:p>
         </p:txBody>
@@ -15489,7 +15546,7 @@
                 <a:ea typeface="Aptos"/>
                 <a:cs typeface="Aptos"/>
               </a:rPr>
-              <a:t>84.6s CPU-only; no network; Docker + one command</a:t>
+              <a:t>Native: 84.6s  |  Docker reproduction: 162.8s  |  no network</a:t>
             </a:r>
           </a:p>
         </p:txBody>

</xml_diff>